<commit_message>
Remove the specific percentage from the presentation and just say rejection is a common complication. If you want to mention our dataset's rate, be explicit: "in our cohort, 29% of studies (21 of 55 patients) involved rejection" . Don't present our single-hospital number as if it's a general medical statistic
</commit_message>
<xml_diff>
--- a/analysis/presentations/spring_event_presentation_final.pptx
+++ b/analysis/presentations/spring_event_presentation_final.pptx
@@ -249,7 +249,7 @@
       <p15:sldGuideLst xmlns:p15="http://schemas.microsoft.com/office/powerpoint/2012/main"/>
     </p:ext>
     <p:ext uri="GoogleSlidesCustomDataVersion2">
-      <go:slidesCustomData xmlns="" xmlns:mc="http://schemas.openxmlformats.org/markup-compatibility/2006" xmlns:mv="urn:schemas-microsoft-com:mac:vml" xmlns:c="http://schemas.openxmlformats.org/drawingml/2006/chart" xmlns:dgm="http://schemas.openxmlformats.org/drawingml/2006/diagram" xmlns:o="urn:schemas-microsoft-com:office:office" xmlns:v="urn:schemas-microsoft-com:vml" xmlns:pvml="urn:schemas-microsoft-com:office:powerpoint" xmlns:com="http://schemas.openxmlformats.org/drawingml/2006/compatibility" xmlns:p14="http://schemas.microsoft.com/office/powerpoint/2010/main" xmlns:p15="http://schemas.microsoft.com/office/powerpoint/2012/main" xmlns:ahyp="http://schemas.microsoft.com/office/drawing/2018/hyperlinkcolor" xmlns:go="http://customooxmlschemas.google.com/" r:id="rId9" roundtripDataSignature="AMtx7mgDv23Ob6DtTlmZbDcBBY0YCkhGDg=="/>
+      <go:slidesCustomData xmlns:go="http://customooxmlschemas.google.com/" xmlns:ahyp="http://schemas.microsoft.com/office/drawing/2018/hyperlinkcolor" xmlns:p15="http://schemas.microsoft.com/office/powerpoint/2012/main" xmlns:p14="http://schemas.microsoft.com/office/powerpoint/2010/main" xmlns:com="http://schemas.openxmlformats.org/drawingml/2006/compatibility" xmlns:pvml="urn:schemas-microsoft-com:office:powerpoint" xmlns:v="urn:schemas-microsoft-com:vml" xmlns:o="urn:schemas-microsoft-com:office:office" xmlns:dgm="http://schemas.openxmlformats.org/drawingml/2006/diagram" xmlns:c="http://schemas.openxmlformats.org/drawingml/2006/chart" xmlns:mv="urn:schemas-microsoft-com:mac:vml" xmlns:mc="http://schemas.openxmlformats.org/markup-compatibility/2006" xmlns="" r:id="rId9" roundtripDataSignature="AMtx7mgDv23Ob6DtTlmZbDcBBY0YCkhGDg=="/>
     </p:ext>
   </p:extLst>
 </p:presentation>
@@ -15831,21 +15831,14 @@
               </a:spcAft>
             </a:pPr>
             <a:r>
-              <a:rPr lang="en-GB" sz="1400" noProof="0" dirty="0">
+              <a:rPr lang="en-GB" sz="1400">
                 <a:solidFill>
                   <a:srgbClr val="333333"/>
                 </a:solidFill>
                 <a:latin typeface="Verdana"/>
               </a:rPr>
-              <a:t>Graft rejection affects ~30% of patients.</a:t>
+              <a:t>Current </a:t>
             </a:r>
-          </a:p>
-          <a:p>
-            <a:pPr lvl="1">
-              <a:spcAft>
-                <a:spcPts val="200"/>
-              </a:spcAft>
-            </a:pPr>
             <a:r>
               <a:rPr lang="en-GB" sz="1400" dirty="0">
                 <a:solidFill>
@@ -15853,7 +15846,7 @@
                 </a:solidFill>
                 <a:latin typeface="Verdana"/>
               </a:rPr>
-              <a:t>Current diagnosis relies on invasive biopsy involving risk of complications, delayed results, and high cost.</a:t>
+              <a:t>diagnosis relies on invasive biopsy involving risk of complications, delayed results, and high cost.</a:t>
             </a:r>
             <a:endParaRPr lang="en-GB" sz="1400" noProof="0" dirty="0">
               <a:solidFill>

</xml_diff>